<commit_message>
Slides: add detailed speaker notes (pptx) + collapsible presenter notes (html) explaining how Harmony and scVI work
Co-Authored-By: Claude Opus 4.8 <noreply@anthropic.com>
</commit_message>
<xml_diff>
--- a/docs/integration_harmony_scvi_slides.pptx
+++ b/docs/integration_harmony_scvi_slides.pptx
@@ -110,6 +110,776 @@
     </a:lvl9pPr>
   </p:defaultTextStyle>
 </p:presentation>
+</file>
+
+<file path=ppt/notesMasters/notesMaster1.xml><?xml version="1.0" encoding="utf-8"?>
+<p:notesMaster xmlns:a="http://schemas.openxmlformats.org/drawingml/2006/main" xmlns:p="http://schemas.openxmlformats.org/presentationml/2006/main" xmlns:r="http://schemas.openxmlformats.org/officeDocument/2006/relationships">
+  <p:cSld>
+    <p:bg>
+      <p:bgRef idx="1001">
+        <a:schemeClr val="bg1"/>
+      </p:bgRef>
+    </p:bg>
+    <p:spTree>
+      <p:nvGrpSpPr>
+        <p:cNvPr id="1" name=""/>
+        <p:cNvGrpSpPr/>
+        <p:nvPr/>
+      </p:nvGrpSpPr>
+      <p:grpSpPr>
+        <a:xfrm>
+          <a:off x="0" y="0"/>
+          <a:ext cx="0" cy="0"/>
+          <a:chOff x="0" y="0"/>
+          <a:chExt cx="0" cy="0"/>
+        </a:xfrm>
+      </p:grpSpPr>
+      <p:sp>
+        <p:nvSpPr>
+          <p:cNvPr id="2" name="Header Placeholder 1"/>
+          <p:cNvSpPr>
+            <a:spLocks noGrp="1"/>
+          </p:cNvSpPr>
+          <p:nvPr>
+            <p:ph type="hdr" sz="quarter"/>
+          </p:nvPr>
+        </p:nvSpPr>
+        <p:spPr>
+          <a:xfrm>
+            <a:off x="0" y="0"/>
+            <a:ext cx="2971800" cy="457200"/>
+          </a:xfrm>
+          <a:prstGeom prst="rect">
+            <a:avLst/>
+          </a:prstGeom>
+        </p:spPr>
+        <p:txBody>
+          <a:bodyPr vert="horz" lIns="91440" tIns="45720" rIns="91440" bIns="45720" rtlCol="0"/>
+          <a:lstStyle>
+            <a:lvl1pPr algn="l">
+              <a:defRPr sz="1200"/>
+            </a:lvl1pPr>
+          </a:lstStyle>
+          <a:p>
+            <a:endParaRPr lang="en-US"/>
+          </a:p>
+        </p:txBody>
+      </p:sp>
+      <p:sp>
+        <p:nvSpPr>
+          <p:cNvPr id="3" name="Date Placeholder 2"/>
+          <p:cNvSpPr>
+            <a:spLocks noGrp="1"/>
+          </p:cNvSpPr>
+          <p:nvPr>
+            <p:ph type="dt" idx="1"/>
+          </p:nvPr>
+        </p:nvSpPr>
+        <p:spPr>
+          <a:xfrm>
+            <a:off x="3884613" y="0"/>
+            <a:ext cx="2971800" cy="457200"/>
+          </a:xfrm>
+          <a:prstGeom prst="rect">
+            <a:avLst/>
+          </a:prstGeom>
+        </p:spPr>
+        <p:txBody>
+          <a:bodyPr vert="horz" lIns="91440" tIns="45720" rIns="91440" bIns="45720" rtlCol="0"/>
+          <a:lstStyle>
+            <a:lvl1pPr algn="r">
+              <a:defRPr sz="1200"/>
+            </a:lvl1pPr>
+          </a:lstStyle>
+          <a:p>
+            <a:fld id="{0F89C1C7-3DCD-1040-A9CF-14679D8B5DDD}" type="datetimeFigureOut">
+              <a:rPr lang="en-US" smtClean="0"/>
+              <a:t>10/17/16</a:t>
+            </a:fld>
+            <a:endParaRPr lang="en-US"/>
+          </a:p>
+        </p:txBody>
+      </p:sp>
+      <p:sp>
+        <p:nvSpPr>
+          <p:cNvPr id="4" name="Slide Image Placeholder 3"/>
+          <p:cNvSpPr>
+            <a:spLocks noGrp="1" noRot="1" noChangeAspect="1"/>
+          </p:cNvSpPr>
+          <p:nvPr>
+            <p:ph type="sldImg" idx="2"/>
+          </p:nvPr>
+        </p:nvSpPr>
+        <p:spPr>
+          <a:xfrm>
+            <a:off x="1143000" y="685800"/>
+            <a:ext cx="4572000" cy="3429000"/>
+          </a:xfrm>
+          <a:prstGeom prst="rect">
+            <a:avLst/>
+          </a:prstGeom>
+          <a:noFill/>
+          <a:ln w="12700">
+            <a:solidFill>
+              <a:prstClr val="black"/>
+            </a:solidFill>
+          </a:ln>
+        </p:spPr>
+        <p:txBody>
+          <a:bodyPr vert="horz" lIns="91440" tIns="45720" rIns="91440" bIns="45720" rtlCol="0" anchor="ctr"/>
+          <a:lstStyle/>
+          <a:p>
+            <a:endParaRPr lang="en-US"/>
+          </a:p>
+        </p:txBody>
+      </p:sp>
+      <p:sp>
+        <p:nvSpPr>
+          <p:cNvPr id="5" name="Notes Placeholder 4"/>
+          <p:cNvSpPr>
+            <a:spLocks noGrp="1"/>
+          </p:cNvSpPr>
+          <p:nvPr>
+            <p:ph type="body" sz="quarter" idx="3"/>
+          </p:nvPr>
+        </p:nvSpPr>
+        <p:spPr>
+          <a:xfrm>
+            <a:off x="685800" y="4343400"/>
+            <a:ext cx="5486400" cy="4114800"/>
+          </a:xfrm>
+          <a:prstGeom prst="rect">
+            <a:avLst/>
+          </a:prstGeom>
+        </p:spPr>
+        <p:txBody>
+          <a:bodyPr vert="horz" lIns="91440" tIns="45720" rIns="91440" bIns="45720" rtlCol="0"/>
+          <a:lstStyle/>
+          <a:p>
+            <a:pPr lvl="0"/>
+            <a:r>
+              <a:rPr lang="en-US" smtClean="0"/>
+              <a:t>Click to edit Master text styles</a:t>
+            </a:r>
+          </a:p>
+          <a:p>
+            <a:pPr lvl="1"/>
+            <a:r>
+              <a:rPr lang="en-US" smtClean="0"/>
+              <a:t>Second level</a:t>
+            </a:r>
+          </a:p>
+          <a:p>
+            <a:pPr lvl="2"/>
+            <a:r>
+              <a:rPr lang="en-US" smtClean="0"/>
+              <a:t>Third level</a:t>
+            </a:r>
+          </a:p>
+          <a:p>
+            <a:pPr lvl="3"/>
+            <a:r>
+              <a:rPr lang="en-US" smtClean="0"/>
+              <a:t>Fourth level</a:t>
+            </a:r>
+          </a:p>
+          <a:p>
+            <a:pPr lvl="4"/>
+            <a:r>
+              <a:rPr lang="en-US" smtClean="0"/>
+              <a:t>Fifth level</a:t>
+            </a:r>
+            <a:endParaRPr lang="en-US"/>
+          </a:p>
+        </p:txBody>
+      </p:sp>
+      <p:sp>
+        <p:nvSpPr>
+          <p:cNvPr id="6" name="Footer Placeholder 5"/>
+          <p:cNvSpPr>
+            <a:spLocks noGrp="1"/>
+          </p:cNvSpPr>
+          <p:nvPr>
+            <p:ph type="ftr" sz="quarter" idx="4"/>
+          </p:nvPr>
+        </p:nvSpPr>
+        <p:spPr>
+          <a:xfrm>
+            <a:off x="0" y="8685213"/>
+            <a:ext cx="2971800" cy="457200"/>
+          </a:xfrm>
+          <a:prstGeom prst="rect">
+            <a:avLst/>
+          </a:prstGeom>
+        </p:spPr>
+        <p:txBody>
+          <a:bodyPr vert="horz" lIns="91440" tIns="45720" rIns="91440" bIns="45720" rtlCol="0" anchor="b"/>
+          <a:lstStyle>
+            <a:lvl1pPr algn="l">
+              <a:defRPr sz="1200"/>
+            </a:lvl1pPr>
+          </a:lstStyle>
+          <a:p>
+            <a:endParaRPr lang="en-US"/>
+          </a:p>
+        </p:txBody>
+      </p:sp>
+      <p:sp>
+        <p:nvSpPr>
+          <p:cNvPr id="7" name="Slide Number Placeholder 6"/>
+          <p:cNvSpPr>
+            <a:spLocks noGrp="1"/>
+          </p:cNvSpPr>
+          <p:nvPr>
+            <p:ph type="sldNum" sz="quarter" idx="5"/>
+          </p:nvPr>
+        </p:nvSpPr>
+        <p:spPr>
+          <a:xfrm>
+            <a:off x="3884613" y="8685213"/>
+            <a:ext cx="2971800" cy="457200"/>
+          </a:xfrm>
+          <a:prstGeom prst="rect">
+            <a:avLst/>
+          </a:prstGeom>
+        </p:spPr>
+        <p:txBody>
+          <a:bodyPr vert="horz" lIns="91440" tIns="45720" rIns="91440" bIns="45720" rtlCol="0" anchor="b"/>
+          <a:lstStyle>
+            <a:lvl1pPr algn="r">
+              <a:defRPr sz="1200"/>
+            </a:lvl1pPr>
+          </a:lstStyle>
+          <a:p>
+            <a:fld id="{BB5E49A5-4136-284D-997B-48E1D791AD67}" type="slidenum">
+              <a:rPr lang="en-US" smtClean="0"/>
+              <a:t>‹#›</a:t>
+            </a:fld>
+            <a:endParaRPr lang="en-US"/>
+          </a:p>
+        </p:txBody>
+      </p:sp>
+    </p:spTree>
+    <p:extLst>
+      <p:ext uri="{BB962C8B-B14F-4D97-AF65-F5344CB8AC3E}">
+        <p14:creationId xmlns:p14="http://schemas.microsoft.com/office/powerpoint/2010/main" val="2623252185"/>
+      </p:ext>
+    </p:extLst>
+  </p:cSld>
+  <p:clrMap bg1="lt1" tx1="dk1" bg2="lt2" tx2="dk2" accent1="accent1" accent2="accent2" accent3="accent3" accent4="accent4" accent5="accent5" accent6="accent6" hlink="hlink" folHlink="folHlink"/>
+  <p:notesStyle>
+    <a:lvl1pPr marL="0" algn="l" defTabSz="457200" rtl="0" eaLnBrk="1" latinLnBrk="0" hangingPunct="1">
+      <a:defRPr sz="1200" kern="1200">
+        <a:solidFill>
+          <a:schemeClr val="tx1"/>
+        </a:solidFill>
+        <a:latin typeface="+mn-lt"/>
+        <a:ea typeface="+mn-ea"/>
+        <a:cs typeface="+mn-cs"/>
+      </a:defRPr>
+    </a:lvl1pPr>
+    <a:lvl2pPr marL="457200" algn="l" defTabSz="457200" rtl="0" eaLnBrk="1" latinLnBrk="0" hangingPunct="1">
+      <a:defRPr sz="1200" kern="1200">
+        <a:solidFill>
+          <a:schemeClr val="tx1"/>
+        </a:solidFill>
+        <a:latin typeface="+mn-lt"/>
+        <a:ea typeface="+mn-ea"/>
+        <a:cs typeface="+mn-cs"/>
+      </a:defRPr>
+    </a:lvl2pPr>
+    <a:lvl3pPr marL="914400" algn="l" defTabSz="457200" rtl="0" eaLnBrk="1" latinLnBrk="0" hangingPunct="1">
+      <a:defRPr sz="1200" kern="1200">
+        <a:solidFill>
+          <a:schemeClr val="tx1"/>
+        </a:solidFill>
+        <a:latin typeface="+mn-lt"/>
+        <a:ea typeface="+mn-ea"/>
+        <a:cs typeface="+mn-cs"/>
+      </a:defRPr>
+    </a:lvl3pPr>
+    <a:lvl4pPr marL="1371600" algn="l" defTabSz="457200" rtl="0" eaLnBrk="1" latinLnBrk="0" hangingPunct="1">
+      <a:defRPr sz="1200" kern="1200">
+        <a:solidFill>
+          <a:schemeClr val="tx1"/>
+        </a:solidFill>
+        <a:latin typeface="+mn-lt"/>
+        <a:ea typeface="+mn-ea"/>
+        <a:cs typeface="+mn-cs"/>
+      </a:defRPr>
+    </a:lvl4pPr>
+    <a:lvl5pPr marL="1828800" algn="l" defTabSz="457200" rtl="0" eaLnBrk="1" latinLnBrk="0" hangingPunct="1">
+      <a:defRPr sz="1200" kern="1200">
+        <a:solidFill>
+          <a:schemeClr val="tx1"/>
+        </a:solidFill>
+        <a:latin typeface="+mn-lt"/>
+        <a:ea typeface="+mn-ea"/>
+        <a:cs typeface="+mn-cs"/>
+      </a:defRPr>
+    </a:lvl5pPr>
+    <a:lvl6pPr marL="2286000" algn="l" defTabSz="457200" rtl="0" eaLnBrk="1" latinLnBrk="0" hangingPunct="1">
+      <a:defRPr sz="1200" kern="1200">
+        <a:solidFill>
+          <a:schemeClr val="tx1"/>
+        </a:solidFill>
+        <a:latin typeface="+mn-lt"/>
+        <a:ea typeface="+mn-ea"/>
+        <a:cs typeface="+mn-cs"/>
+      </a:defRPr>
+    </a:lvl6pPr>
+    <a:lvl7pPr marL="2743200" algn="l" defTabSz="457200" rtl="0" eaLnBrk="1" latinLnBrk="0" hangingPunct="1">
+      <a:defRPr sz="1200" kern="1200">
+        <a:solidFill>
+          <a:schemeClr val="tx1"/>
+        </a:solidFill>
+        <a:latin typeface="+mn-lt"/>
+        <a:ea typeface="+mn-ea"/>
+        <a:cs typeface="+mn-cs"/>
+      </a:defRPr>
+    </a:lvl7pPr>
+    <a:lvl8pPr marL="3200400" algn="l" defTabSz="457200" rtl="0" eaLnBrk="1" latinLnBrk="0" hangingPunct="1">
+      <a:defRPr sz="1200" kern="1200">
+        <a:solidFill>
+          <a:schemeClr val="tx1"/>
+        </a:solidFill>
+        <a:latin typeface="+mn-lt"/>
+        <a:ea typeface="+mn-ea"/>
+        <a:cs typeface="+mn-cs"/>
+      </a:defRPr>
+    </a:lvl8pPr>
+    <a:lvl9pPr marL="3657600" algn="l" defTabSz="457200" rtl="0" eaLnBrk="1" latinLnBrk="0" hangingPunct="1">
+      <a:defRPr sz="1200" kern="1200">
+        <a:solidFill>
+          <a:schemeClr val="tx1"/>
+        </a:solidFill>
+        <a:latin typeface="+mn-lt"/>
+        <a:ea typeface="+mn-ea"/>
+        <a:cs typeface="+mn-cs"/>
+      </a:defRPr>
+    </a:lvl9pPr>
+  </p:notesStyle>
+</p:notesMaster>
+</file>
+
+<file path=ppt/notesSlides/notesSlide1.xml><?xml version="1.0" encoding="utf-8"?>
+<p:notes xmlns:a="http://schemas.openxmlformats.org/drawingml/2006/main" xmlns:p="http://schemas.openxmlformats.org/presentationml/2006/main" xmlns:r="http://schemas.openxmlformats.org/officeDocument/2006/relationships">
+  <p:cSld>
+    <p:spTree>
+      <p:nvGrpSpPr>
+        <p:cNvPr id="1" name=""/>
+        <p:cNvGrpSpPr/>
+        <p:nvPr/>
+      </p:nvGrpSpPr>
+      <p:grpSpPr>
+        <a:xfrm>
+          <a:off x="0" y="0"/>
+          <a:ext cx="0" cy="0"/>
+          <a:chOff x="0" y="0"/>
+          <a:chExt cx="0" cy="0"/>
+        </a:xfrm>
+      </p:grpSpPr>
+      <p:sp>
+        <p:nvSpPr>
+          <p:cNvPr id="2" name="Slide Image Placeholder 1"/>
+          <p:cNvSpPr>
+            <a:spLocks noGrp="1"/>
+          </p:cNvSpPr>
+          <p:nvPr>
+            <p:ph type="sldImg" idx="2"/>
+          </p:nvPr>
+        </p:nvSpPr>
+        <p:spPr/>
+      </p:sp>
+      <p:sp>
+        <p:nvSpPr>
+          <p:cNvPr id="3" name="Notes Placeholder 2"/>
+          <p:cNvSpPr>
+            <a:spLocks noGrp="1"/>
+          </p:cNvSpPr>
+          <p:nvPr>
+            <p:ph type="body" idx="3" sz="quarter"/>
+          </p:nvPr>
+        </p:nvSpPr>
+        <p:spPr/>
+        <p:txBody>
+          <a:bodyPr/>
+          <a:lstStyle/>
+          <a:p>
+            <a:r>
+              <a:t>When we combine cells from several donors, samples, or sequencing runs, the strongest signals in the data are often technical — which sample a cell came from — rather than biological. Integration removes that technical (batch) structure while keeping the real biology, so the same cell type from different samples lines up. This deck covers the principle, then the two methods the notebook uses — Harmony and scVI — and how they compare.</a:t>
+            </a:r>
+          </a:p>
+        </p:txBody>
+      </p:sp>
+      <p:sp>
+        <p:nvSpPr>
+          <p:cNvPr id="4" name="Slide Number Placeholder 3"/>
+          <p:cNvSpPr>
+            <a:spLocks noGrp="1"/>
+          </p:cNvSpPr>
+          <p:nvPr>
+            <p:ph type="sldNum" idx="5" sz="quarter"/>
+          </p:nvPr>
+        </p:nvSpPr>
+        <p:spPr/>
+      </p:sp>
+    </p:spTree>
+  </p:cSld>
+  <p:clrMapOvr>
+    <a:masterClrMapping/>
+  </p:clrMapOvr>
+</p:notes>
+</file>
+
+<file path=ppt/notesSlides/notesSlide2.xml><?xml version="1.0" encoding="utf-8"?>
+<p:notes xmlns:a="http://schemas.openxmlformats.org/drawingml/2006/main" xmlns:p="http://schemas.openxmlformats.org/presentationml/2006/main" xmlns:r="http://schemas.openxmlformats.org/officeDocument/2006/relationships">
+  <p:cSld>
+    <p:spTree>
+      <p:nvGrpSpPr>
+        <p:cNvPr id="1" name=""/>
+        <p:cNvGrpSpPr/>
+        <p:nvPr/>
+      </p:nvGrpSpPr>
+      <p:grpSpPr>
+        <a:xfrm>
+          <a:off x="0" y="0"/>
+          <a:ext cx="0" cy="0"/>
+          <a:chOff x="0" y="0"/>
+          <a:chExt cx="0" cy="0"/>
+        </a:xfrm>
+      </p:grpSpPr>
+      <p:sp>
+        <p:nvSpPr>
+          <p:cNvPr id="2" name="Slide Image Placeholder 1"/>
+          <p:cNvSpPr>
+            <a:spLocks noGrp="1"/>
+          </p:cNvSpPr>
+          <p:nvPr>
+            <p:ph type="sldImg" idx="2"/>
+          </p:nvPr>
+        </p:nvSpPr>
+        <p:spPr/>
+      </p:sp>
+      <p:sp>
+        <p:nvSpPr>
+          <p:cNvPr id="3" name="Notes Placeholder 2"/>
+          <p:cNvSpPr>
+            <a:spLocks noGrp="1"/>
+          </p:cNvSpPr>
+          <p:nvPr>
+            <p:ph type="body" idx="3" sz="quarter"/>
+          </p:nvPr>
+        </p:nvSpPr>
+        <p:spPr/>
+        <p:txBody>
+          <a:bodyPr/>
+          <a:lstStyle/>
+          <a:p>
+            <a:r>
+              <a:t>The core problem is that batch effects and biology are partly confounded. If donor identity drives the top axes of variation, naive clustering splits each cell type by donor — you get 'donor-A T cells' and 'donor-B T cells' as separate clusters, which is wrong. The goal of integration is to remove technical variation while preserving biological signal, so shared populations align across samples. Diagnose it visually: colour the UMAP by donor — separation by donor means biology is confounded by batch; good integration mixes donors within each cell type. Every method balances a tension: mix batches enough, but do not over-correct and merge genuinely distinct cell types. Because batch and biology are entangled, each method needs assumptions about how to tell them apart — that is where Harmony and scVI differ.</a:t>
+            </a:r>
+          </a:p>
+        </p:txBody>
+      </p:sp>
+      <p:sp>
+        <p:nvSpPr>
+          <p:cNvPr id="4" name="Slide Number Placeholder 3"/>
+          <p:cNvSpPr>
+            <a:spLocks noGrp="1"/>
+          </p:cNvSpPr>
+          <p:nvPr>
+            <p:ph type="sldNum" idx="5" sz="quarter"/>
+          </p:nvPr>
+        </p:nvSpPr>
+        <p:spPr/>
+      </p:sp>
+    </p:spTree>
+  </p:cSld>
+  <p:clrMapOvr>
+    <a:masterClrMapping/>
+  </p:clrMapOvr>
+</p:notes>
+</file>
+
+<file path=ppt/notesSlides/notesSlide3.xml><?xml version="1.0" encoding="utf-8"?>
+<p:notes xmlns:a="http://schemas.openxmlformats.org/drawingml/2006/main" xmlns:p="http://schemas.openxmlformats.org/presentationml/2006/main" xmlns:r="http://schemas.openxmlformats.org/officeDocument/2006/relationships">
+  <p:cSld>
+    <p:spTree>
+      <p:nvGrpSpPr>
+        <p:cNvPr id="1" name=""/>
+        <p:cNvGrpSpPr/>
+        <p:nvPr/>
+      </p:nvGrpSpPr>
+      <p:grpSpPr>
+        <a:xfrm>
+          <a:off x="0" y="0"/>
+          <a:ext cx="0" cy="0"/>
+          <a:chOff x="0" y="0"/>
+          <a:chExt cx="0" cy="0"/>
+        </a:xfrm>
+      </p:grpSpPr>
+      <p:sp>
+        <p:nvSpPr>
+          <p:cNvPr id="2" name="Slide Image Placeholder 1"/>
+          <p:cNvSpPr>
+            <a:spLocks noGrp="1"/>
+          </p:cNvSpPr>
+          <p:nvPr>
+            <p:ph type="sldImg" idx="2"/>
+          </p:nvPr>
+        </p:nvSpPr>
+        <p:spPr/>
+      </p:sp>
+      <p:sp>
+        <p:nvSpPr>
+          <p:cNvPr id="3" name="Notes Placeholder 2"/>
+          <p:cNvSpPr>
+            <a:spLocks noGrp="1"/>
+          </p:cNvSpPr>
+          <p:nvPr>
+            <p:ph type="body" idx="3" sz="quarter"/>
+          </p:nvPr>
+        </p:nvSpPr>
+        <p:spPr/>
+        <p:txBody>
+          <a:bodyPr/>
+          <a:lstStyle/>
+          <a:p>
+            <a:r>
+              <a:t>Harmony corrects an existing PCA embedding — it never revisits genes, it just moves points in PC space. It iterates two steps to convergence. Step 1, maximum-diversity soft clustering: it soft-clusters all cells (fuzzy k-means, partial memberships) but penalises clusters dominated by a single batch, so clusters correspond to cell types (which span batches) rather than to batches. Step 2, per-cluster correction: within each cluster it measures how far each batch's centroid sits from the cluster centroid — that offset is the batch effect for that cell type — and subtracts a membership-weighted version from each cell. The key idea is that the correction is cluster-specific, so a batch effect that looks different in T cells vs neurons is removed appropriately, rather than one global shift. It is linear-ish, has no neural network to train, runs in seconds on CPU, and stays in the interpretable PCA space — a great default. Limits: it can only correct what PCA captured, and it assumes the within-cell-type batch effect is roughly a location shift.</a:t>
+            </a:r>
+          </a:p>
+        </p:txBody>
+      </p:sp>
+      <p:sp>
+        <p:nvSpPr>
+          <p:cNvPr id="4" name="Slide Number Placeholder 3"/>
+          <p:cNvSpPr>
+            <a:spLocks noGrp="1"/>
+          </p:cNvSpPr>
+          <p:nvPr>
+            <p:ph type="sldNum" idx="5" sz="quarter"/>
+          </p:nvPr>
+        </p:nvSpPr>
+        <p:spPr/>
+      </p:sp>
+    </p:spTree>
+  </p:cSld>
+  <p:clrMapOvr>
+    <a:masterClrMapping/>
+  </p:clrMapOvr>
+</p:notes>
+</file>
+
+<file path=ppt/notesSlides/notesSlide4.xml><?xml version="1.0" encoding="utf-8"?>
+<p:notes xmlns:a="http://schemas.openxmlformats.org/drawingml/2006/main" xmlns:p="http://schemas.openxmlformats.org/presentationml/2006/main" xmlns:r="http://schemas.openxmlformats.org/officeDocument/2006/relationships">
+  <p:cSld>
+    <p:spTree>
+      <p:nvGrpSpPr>
+        <p:cNvPr id="1" name=""/>
+        <p:cNvGrpSpPr/>
+        <p:nvPr/>
+      </p:nvGrpSpPr>
+      <p:grpSpPr>
+        <a:xfrm>
+          <a:off x="0" y="0"/>
+          <a:ext cx="0" cy="0"/>
+          <a:chOff x="0" y="0"/>
+          <a:chExt cx="0" cy="0"/>
+        </a:xfrm>
+      </p:grpSpPr>
+      <p:sp>
+        <p:nvSpPr>
+          <p:cNvPr id="2" name="Slide Image Placeholder 1"/>
+          <p:cNvSpPr>
+            <a:spLocks noGrp="1"/>
+          </p:cNvSpPr>
+          <p:nvPr>
+            <p:ph type="sldImg" idx="2"/>
+          </p:nvPr>
+        </p:nvSpPr>
+        <p:spPr/>
+      </p:sp>
+      <p:sp>
+        <p:nvSpPr>
+          <p:cNvPr id="3" name="Notes Placeholder 2"/>
+          <p:cNvSpPr>
+            <a:spLocks noGrp="1"/>
+          </p:cNvSpPr>
+          <p:nvPr>
+            <p:ph type="body" idx="3" sz="quarter"/>
+          </p:nvPr>
+        </p:nvSpPr>
+        <p:spPr/>
+        <p:txBody>
+          <a:bodyPr/>
+          <a:lstStyle/>
+          <a:p>
+            <a:r>
+              <a:t>scVI throws out the PCA and models the raw UMI counts directly with a variational autoencoder. Generative story: each cell has an unobserved low-dimensional latent vector z capturing its biological state; a neural-network decoder maps z PLUS the batch label to the parameters of a negative-binomial count distribution for every gene, also accounting for library size. Because batch is fed in explicitly, the model can explain batch-driven differences through that input, leaving z batch-free — that is how integration happens. Training is variational inference: an encoder approximates the posterior over z, and we maximise the ELBO = reconstruction (does the NB decoder explain the observed counts?) minus a KL term keeping z near a standard-normal prior, via stochastic gradient descent over epochs. The output is the per-cell latent z, used like Harmony's embedding. Because it is a full probabilistic count model, you also get denoised expression, differential expression with uncertainty, and a whole family (scANVI for labels, totalVI for CITE-seq). It is non-linear and scales well but is GPU-preferred — slow on CPU at scale, which is why the course loads a precomputed full-data latent and only trains a small subsample as a proof of concept. It is more of a black box; results depend on architecture, epochs, and seed.</a:t>
+            </a:r>
+          </a:p>
+        </p:txBody>
+      </p:sp>
+      <p:sp>
+        <p:nvSpPr>
+          <p:cNvPr id="4" name="Slide Number Placeholder 3"/>
+          <p:cNvSpPr>
+            <a:spLocks noGrp="1"/>
+          </p:cNvSpPr>
+          <p:nvPr>
+            <p:ph type="sldNum" idx="5" sz="quarter"/>
+          </p:nvPr>
+        </p:nvSpPr>
+        <p:spPr/>
+      </p:sp>
+    </p:spTree>
+  </p:cSld>
+  <p:clrMapOvr>
+    <a:masterClrMapping/>
+  </p:clrMapOvr>
+</p:notes>
+</file>
+
+<file path=ppt/notesSlides/notesSlide5.xml><?xml version="1.0" encoding="utf-8"?>
+<p:notes xmlns:a="http://schemas.openxmlformats.org/drawingml/2006/main" xmlns:p="http://schemas.openxmlformats.org/presentationml/2006/main" xmlns:r="http://schemas.openxmlformats.org/officeDocument/2006/relationships">
+  <p:cSld>
+    <p:spTree>
+      <p:nvGrpSpPr>
+        <p:cNvPr id="1" name=""/>
+        <p:cNvGrpSpPr/>
+        <p:nvPr/>
+      </p:nvGrpSpPr>
+      <p:grpSpPr>
+        <a:xfrm>
+          <a:off x="0" y="0"/>
+          <a:ext cx="0" cy="0"/>
+          <a:chOff x="0" y="0"/>
+          <a:chExt cx="0" cy="0"/>
+        </a:xfrm>
+      </p:grpSpPr>
+      <p:sp>
+        <p:nvSpPr>
+          <p:cNvPr id="2" name="Slide Image Placeholder 1"/>
+          <p:cNvSpPr>
+            <a:spLocks noGrp="1"/>
+          </p:cNvSpPr>
+          <p:nvPr>
+            <p:ph type="sldImg" idx="2"/>
+          </p:nvPr>
+        </p:nvSpPr>
+        <p:spPr/>
+      </p:sp>
+      <p:sp>
+        <p:nvSpPr>
+          <p:cNvPr id="3" name="Notes Placeholder 2"/>
+          <p:cNvSpPr>
+            <a:spLocks noGrp="1"/>
+          </p:cNvSpPr>
+          <p:nvPr>
+            <p:ph type="body" idx="3" sz="quarter"/>
+          </p:nvPr>
+        </p:nvSpPr>
+        <p:spPr/>
+        <p:txBody>
+          <a:bodyPr/>
+          <a:lstStyle/>
+          <a:p>
+            <a:r>
+              <a:t>Walking the rows: Model type — Harmony is iterative clustering plus a linear correction; scVI is a deep generative VAE. Input — Harmony corrects your PCA; scVI models raw counts with batch as a covariate. Speed — Harmony is fast and CPU-friendly (seconds); scVI is slower and GPU-preferred. Scalability — both scale, scVI especially to millions of cells. Extras — scVI gives denoising, DE, and uncertainty that Harmony cannot; Harmony's advantage is simplicity, robustness, and an interpretable space. Failure modes: Harmony can only fix what PCA saw and assumes shift-like batch effects; scVI can over- or under-correct and is sensitive to epochs and architecture. Practical rule: Harmony as a fast first pass, scVI when you have a GPU, large data, or want the generative extras.</a:t>
+            </a:r>
+          </a:p>
+        </p:txBody>
+      </p:sp>
+      <p:sp>
+        <p:nvSpPr>
+          <p:cNvPr id="4" name="Slide Number Placeholder 3"/>
+          <p:cNvSpPr>
+            <a:spLocks noGrp="1"/>
+          </p:cNvSpPr>
+          <p:nvPr>
+            <p:ph type="sldNum" idx="5" sz="quarter"/>
+          </p:nvPr>
+        </p:nvSpPr>
+        <p:spPr/>
+      </p:sp>
+    </p:spTree>
+  </p:cSld>
+  <p:clrMapOvr>
+    <a:masterClrMapping/>
+  </p:clrMapOvr>
+</p:notes>
+</file>
+
+<file path=ppt/notesSlides/notesSlide6.xml><?xml version="1.0" encoding="utf-8"?>
+<p:notes xmlns:a="http://schemas.openxmlformats.org/drawingml/2006/main" xmlns:p="http://schemas.openxmlformats.org/presentationml/2006/main" xmlns:r="http://schemas.openxmlformats.org/officeDocument/2006/relationships">
+  <p:cSld>
+    <p:spTree>
+      <p:nvGrpSpPr>
+        <p:cNvPr id="1" name=""/>
+        <p:cNvGrpSpPr/>
+        <p:nvPr/>
+      </p:nvGrpSpPr>
+      <p:grpSpPr>
+        <a:xfrm>
+          <a:off x="0" y="0"/>
+          <a:ext cx="0" cy="0"/>
+          <a:chOff x="0" y="0"/>
+          <a:chExt cx="0" cy="0"/>
+        </a:xfrm>
+      </p:grpSpPr>
+      <p:sp>
+        <p:nvSpPr>
+          <p:cNvPr id="2" name="Slide Image Placeholder 1"/>
+          <p:cNvSpPr>
+            <a:spLocks noGrp="1"/>
+          </p:cNvSpPr>
+          <p:nvPr>
+            <p:ph type="sldImg" idx="2"/>
+          </p:nvPr>
+        </p:nvSpPr>
+        <p:spPr/>
+      </p:sp>
+      <p:sp>
+        <p:nvSpPr>
+          <p:cNvPr id="3" name="Notes Placeholder 2"/>
+          <p:cNvSpPr>
+            <a:spLocks noGrp="1"/>
+          </p:cNvSpPr>
+          <p:nvPr>
+            <p:ph type="body" idx="3" sz="quarter"/>
+          </p:nvPr>
+        </p:nvSpPr>
+        <p:spPr/>
+        <p:txBody>
+          <a:bodyPr/>
+          <a:lstStyle/>
+          <a:p>
+            <a:r>
+              <a:t>How to actually judge integration — check two things at once. Mixing: do donors overlap? Quantify with the same-donor neighbour fraction — for each cell, the fraction of its k nearest neighbours from the same donor; it should drop from about 1.0 (no correction) toward each donor's global share (perfect mixing). Biology preserved: do known cell types still separate? Good integration improves mixing WITHOUT smearing distinct cell types together. In the notebook you run neighbours+UMAP on each embedding, colour by donor and by cell type, and compute that neighbour-purity metric; in the two-donor teaching run the methods perform comparably, so we proceed with Harmony (seconds vs minutes on CPU) but keep X_scvi so you can flip the INTEGRATION_METHOD flag and reproduce everything with scVI. One-line intuition: Harmony nudges points in PCA space so batches mix within each cell-type cluster; scVI learns a neural latent space of the counts in which the batch variable has been explained away.</a:t>
+            </a:r>
+          </a:p>
+        </p:txBody>
+      </p:sp>
+      <p:sp>
+        <p:nvSpPr>
+          <p:cNvPr id="4" name="Slide Number Placeholder 3"/>
+          <p:cNvSpPr>
+            <a:spLocks noGrp="1"/>
+          </p:cNvSpPr>
+          <p:nvPr>
+            <p:ph type="sldNum" idx="5" sz="quarter"/>
+          </p:nvPr>
+        </p:nvSpPr>
+        <p:spPr/>
+      </p:sp>
+    </p:spTree>
+  </p:cSld>
+  <p:clrMapOvr>
+    <a:masterClrMapping/>
+  </p:clrMapOvr>
+</p:notes>
 </file>
 
 <file path=ppt/slideLayouts/slideLayout1.xml><?xml version="1.0" encoding="utf-8"?>
@@ -15118,4 +15888,324 @@
   </a:objectDefaults>
   <a:extraClrSchemeLst/>
 </a:theme>
+</file>
+
+<file path=ppt/theme/theme2.xml><?xml version="1.0" encoding="utf-8"?>
+<a:theme xmlns:a="http://schemas.openxmlformats.org/drawingml/2006/main" name="Office Theme">
+  <a:themeElements>
+    <a:clrScheme name="Office">
+      <a:dk1>
+        <a:sysClr val="windowText" lastClr="000000"/>
+      </a:dk1>
+      <a:lt1>
+        <a:sysClr val="window" lastClr="FFFFFF"/>
+      </a:lt1>
+      <a:dk2>
+        <a:srgbClr val="1F497D"/>
+      </a:dk2>
+      <a:lt2>
+        <a:srgbClr val="EEECE1"/>
+      </a:lt2>
+      <a:accent1>
+        <a:srgbClr val="4F81BD"/>
+      </a:accent1>
+      <a:accent2>
+        <a:srgbClr val="C0504D"/>
+      </a:accent2>
+      <a:accent3>
+        <a:srgbClr val="9BBB59"/>
+      </a:accent3>
+      <a:accent4>
+        <a:srgbClr val="8064A2"/>
+      </a:accent4>
+      <a:accent5>
+        <a:srgbClr val="4BACC6"/>
+      </a:accent5>
+      <a:accent6>
+        <a:srgbClr val="F79646"/>
+      </a:accent6>
+      <a:hlink>
+        <a:srgbClr val="0000FF"/>
+      </a:hlink>
+      <a:folHlink>
+        <a:srgbClr val="800080"/>
+      </a:folHlink>
+    </a:clrScheme>
+    <a:fontScheme name="Office">
+      <a:majorFont>
+        <a:latin typeface="Calibri"/>
+        <a:ea typeface=""/>
+        <a:cs typeface=""/>
+        <a:font script="Jpan" typeface="ＭＳ Ｐゴシック"/>
+        <a:font script="Hang" typeface="맑은 고딕"/>
+        <a:font script="Hans" typeface="宋体"/>
+        <a:font script="Hant" typeface="新細明體"/>
+        <a:font script="Arab" typeface="Times New Roman"/>
+        <a:font script="Hebr" typeface="Times New Roman"/>
+        <a:font script="Thai" typeface="Angsana New"/>
+        <a:font script="Ethi" typeface="Nyala"/>
+        <a:font script="Beng" typeface="Vrinda"/>
+        <a:font script="Gujr" typeface="Shruti"/>
+        <a:font script="Khmr" typeface="MoolBoran"/>
+        <a:font script="Knda" typeface="Tunga"/>
+        <a:font script="Guru" typeface="Raavi"/>
+        <a:font script="Cans" typeface="Euphemia"/>
+        <a:font script="Cher" typeface="Plantagenet Cherokee"/>
+        <a:font script="Yiii" typeface="Microsoft Yi Baiti"/>
+        <a:font script="Tibt" typeface="Microsoft Himalaya"/>
+        <a:font script="Thaa" typeface="MV Boli"/>
+        <a:font script="Deva" typeface="Mangal"/>
+        <a:font script="Telu" typeface="Gautami"/>
+        <a:font script="Taml" typeface="Latha"/>
+        <a:font script="Syrc" typeface="Estrangelo Edessa"/>
+        <a:font script="Orya" typeface="Kalinga"/>
+        <a:font script="Mlym" typeface="Kartika"/>
+        <a:font script="Laoo" typeface="DokChampa"/>
+        <a:font script="Sinh" typeface="Iskoola Pota"/>
+        <a:font script="Mong" typeface="Mongolian Baiti"/>
+        <a:font script="Viet" typeface="Times New Roman"/>
+        <a:font script="Uigh" typeface="Microsoft Uighur"/>
+        <a:font script="Geor" typeface="Sylfaen"/>
+      </a:majorFont>
+      <a:minorFont>
+        <a:latin typeface="Calibri"/>
+        <a:ea typeface=""/>
+        <a:cs typeface=""/>
+        <a:font script="Jpan" typeface="ＭＳ Ｐゴシック"/>
+        <a:font script="Hang" typeface="맑은 고딕"/>
+        <a:font script="Hans" typeface="宋体"/>
+        <a:font script="Hant" typeface="新細明體"/>
+        <a:font script="Arab" typeface="Arial"/>
+        <a:font script="Hebr" typeface="Arial"/>
+        <a:font script="Thai" typeface="Cordia New"/>
+        <a:font script="Ethi" typeface="Nyala"/>
+        <a:font script="Beng" typeface="Vrinda"/>
+        <a:font script="Gujr" typeface="Shruti"/>
+        <a:font script="Khmr" typeface="DaunPenh"/>
+        <a:font script="Knda" typeface="Tunga"/>
+        <a:font script="Guru" typeface="Raavi"/>
+        <a:font script="Cans" typeface="Euphemia"/>
+        <a:font script="Cher" typeface="Plantagenet Cherokee"/>
+        <a:font script="Yiii" typeface="Microsoft Yi Baiti"/>
+        <a:font script="Tibt" typeface="Microsoft Himalaya"/>
+        <a:font script="Thaa" typeface="MV Boli"/>
+        <a:font script="Deva" typeface="Mangal"/>
+        <a:font script="Telu" typeface="Gautami"/>
+        <a:font script="Taml" typeface="Latha"/>
+        <a:font script="Syrc" typeface="Estrangelo Edessa"/>
+        <a:font script="Orya" typeface="Kalinga"/>
+        <a:font script="Mlym" typeface="Kartika"/>
+        <a:font script="Laoo" typeface="DokChampa"/>
+        <a:font script="Sinh" typeface="Iskoola Pota"/>
+        <a:font script="Mong" typeface="Mongolian Baiti"/>
+        <a:font script="Viet" typeface="Arial"/>
+        <a:font script="Uigh" typeface="Microsoft Uighur"/>
+        <a:font script="Geor" typeface="Sylfaen"/>
+      </a:minorFont>
+    </a:fontScheme>
+    <a:fmtScheme name="Office">
+      <a:fillStyleLst>
+        <a:solidFill>
+          <a:schemeClr val="phClr"/>
+        </a:solidFill>
+        <a:gradFill rotWithShape="1">
+          <a:gsLst>
+            <a:gs pos="0">
+              <a:schemeClr val="phClr">
+                <a:tint val="50000"/>
+                <a:satMod val="300000"/>
+              </a:schemeClr>
+            </a:gs>
+            <a:gs pos="35000">
+              <a:schemeClr val="phClr">
+                <a:tint val="37000"/>
+                <a:satMod val="300000"/>
+              </a:schemeClr>
+            </a:gs>
+            <a:gs pos="100000">
+              <a:schemeClr val="phClr">
+                <a:tint val="15000"/>
+                <a:satMod val="350000"/>
+              </a:schemeClr>
+            </a:gs>
+          </a:gsLst>
+          <a:lin ang="16200000" scaled="1"/>
+        </a:gradFill>
+        <a:gradFill rotWithShape="1">
+          <a:gsLst>
+            <a:gs pos="0">
+              <a:schemeClr val="phClr">
+                <a:tint val="100000"/>
+                <a:shade val="100000"/>
+                <a:satMod val="130000"/>
+              </a:schemeClr>
+            </a:gs>
+            <a:gs pos="100000">
+              <a:schemeClr val="phClr">
+                <a:tint val="50000"/>
+                <a:shade val="100000"/>
+                <a:satMod val="350000"/>
+              </a:schemeClr>
+            </a:gs>
+          </a:gsLst>
+          <a:lin ang="16200000" scaled="0"/>
+        </a:gradFill>
+      </a:fillStyleLst>
+      <a:lnStyleLst>
+        <a:ln w="9525" cap="flat" cmpd="sng" algn="ctr">
+          <a:solidFill>
+            <a:schemeClr val="phClr">
+              <a:shade val="95000"/>
+              <a:satMod val="105000"/>
+            </a:schemeClr>
+          </a:solidFill>
+          <a:prstDash val="solid"/>
+        </a:ln>
+        <a:ln w="25400" cap="flat" cmpd="sng" algn="ctr">
+          <a:solidFill>
+            <a:schemeClr val="phClr"/>
+          </a:solidFill>
+          <a:prstDash val="solid"/>
+        </a:ln>
+        <a:ln w="38100" cap="flat" cmpd="sng" algn="ctr">
+          <a:solidFill>
+            <a:schemeClr val="phClr"/>
+          </a:solidFill>
+          <a:prstDash val="solid"/>
+        </a:ln>
+      </a:lnStyleLst>
+      <a:effectStyleLst>
+        <a:effectStyle>
+          <a:effectLst>
+            <a:outerShdw blurRad="40000" dist="20000" dir="5400000" rotWithShape="0">
+              <a:srgbClr val="000000">
+                <a:alpha val="38000"/>
+              </a:srgbClr>
+            </a:outerShdw>
+          </a:effectLst>
+        </a:effectStyle>
+        <a:effectStyle>
+          <a:effectLst>
+            <a:outerShdw blurRad="40000" dist="23000" dir="5400000" rotWithShape="0">
+              <a:srgbClr val="000000">
+                <a:alpha val="35000"/>
+              </a:srgbClr>
+            </a:outerShdw>
+          </a:effectLst>
+        </a:effectStyle>
+        <a:effectStyle>
+          <a:effectLst>
+            <a:outerShdw blurRad="40000" dist="23000" dir="5400000" rotWithShape="0">
+              <a:srgbClr val="000000">
+                <a:alpha val="35000"/>
+              </a:srgbClr>
+            </a:outerShdw>
+          </a:effectLst>
+          <a:scene3d>
+            <a:camera prst="orthographicFront">
+              <a:rot lat="0" lon="0" rev="0"/>
+            </a:camera>
+            <a:lightRig rig="threePt" dir="t">
+              <a:rot lat="0" lon="0" rev="1200000"/>
+            </a:lightRig>
+          </a:scene3d>
+          <a:sp3d>
+            <a:bevelT w="63500" h="25400"/>
+          </a:sp3d>
+        </a:effectStyle>
+      </a:effectStyleLst>
+      <a:bgFillStyleLst>
+        <a:solidFill>
+          <a:schemeClr val="phClr"/>
+        </a:solidFill>
+        <a:gradFill rotWithShape="1">
+          <a:gsLst>
+            <a:gs pos="0">
+              <a:schemeClr val="phClr">
+                <a:tint val="40000"/>
+                <a:satMod val="350000"/>
+              </a:schemeClr>
+            </a:gs>
+            <a:gs pos="40000">
+              <a:schemeClr val="phClr">
+                <a:tint val="45000"/>
+                <a:shade val="99000"/>
+                <a:satMod val="350000"/>
+              </a:schemeClr>
+            </a:gs>
+            <a:gs pos="100000">
+              <a:schemeClr val="phClr">
+                <a:shade val="20000"/>
+                <a:satMod val="255000"/>
+              </a:schemeClr>
+            </a:gs>
+          </a:gsLst>
+          <a:path path="circle">
+            <a:fillToRect l="50000" t="-80000" r="50000" b="180000"/>
+          </a:path>
+        </a:gradFill>
+        <a:gradFill rotWithShape="1">
+          <a:gsLst>
+            <a:gs pos="0">
+              <a:schemeClr val="phClr">
+                <a:tint val="80000"/>
+                <a:satMod val="300000"/>
+              </a:schemeClr>
+            </a:gs>
+            <a:gs pos="100000">
+              <a:schemeClr val="phClr">
+                <a:shade val="30000"/>
+                <a:satMod val="200000"/>
+              </a:schemeClr>
+            </a:gs>
+          </a:gsLst>
+          <a:path path="circle">
+            <a:fillToRect l="50000" t="50000" r="50000" b="50000"/>
+          </a:path>
+        </a:gradFill>
+      </a:bgFillStyleLst>
+    </a:fmtScheme>
+  </a:themeElements>
+  <a:objectDefaults>
+    <a:spDef>
+      <a:spPr/>
+      <a:bodyPr/>
+      <a:lstStyle/>
+      <a:style>
+        <a:lnRef idx="1">
+          <a:schemeClr val="accent1"/>
+        </a:lnRef>
+        <a:fillRef idx="3">
+          <a:schemeClr val="accent1"/>
+        </a:fillRef>
+        <a:effectRef idx="2">
+          <a:schemeClr val="accent1"/>
+        </a:effectRef>
+        <a:fontRef idx="minor">
+          <a:schemeClr val="lt1"/>
+        </a:fontRef>
+      </a:style>
+    </a:spDef>
+    <a:lnDef>
+      <a:spPr/>
+      <a:bodyPr/>
+      <a:lstStyle/>
+      <a:style>
+        <a:lnRef idx="2">
+          <a:schemeClr val="accent1"/>
+        </a:lnRef>
+        <a:fillRef idx="0">
+          <a:schemeClr val="accent1"/>
+        </a:fillRef>
+        <a:effectRef idx="1">
+          <a:schemeClr val="accent1"/>
+        </a:effectRef>
+        <a:fontRef idx="minor">
+          <a:schemeClr val="tx1"/>
+        </a:fontRef>
+      </a:style>
+    </a:lnDef>
+  </a:objectDefaults>
+  <a:extraClrSchemeLst/>
+</a:theme>
 </file>
</xml_diff>